<commit_message>
PHOV-deck: over naar Eduface-stijl, proefslide 3 opnieuw
Co-Authored-By: Claude Opus 5.5 <noreply@anthropic.com>
Claude-Session: https://claude.ai/code/session_011t24oTGXT853tnxP2SMa8Y
</commit_message>
<xml_diff>
--- a/GTM/Accounts/phov/deck/phov-deck-bewerkbaar.pptx
+++ b/GTM/Accounts/phov/deck/phov-deck-bewerkbaar.pptx
@@ -3090,20 +3090,22 @@
       <p:grpSpPr/>
       <p:sp>
         <p:nvSpPr>
-          <p:cNvPr id="2" name="Rectangle 1"/>
+          <p:cNvPr id="2" name="Rounded Rectangle 1"/>
           <p:cNvSpPr/>
           <p:nvPr/>
         </p:nvSpPr>
         <p:spPr>
           <a:xfrm>
-            <a:off x="0" y="0"/>
-            <a:ext cx="12192000" cy="139700"/>
+            <a:off x="762000" y="952500"/>
+            <a:ext cx="3937000" cy="3937000"/>
           </a:xfrm>
-          <a:prstGeom prst="rect">
-            <a:avLst/>
+          <a:prstGeom prst="roundRect">
+            <a:avLst>
+              <a:gd name="adj" fmla="val 3225"/>
+            </a:avLst>
           </a:prstGeom>
           <a:solidFill>
-            <a:srgbClr val="8CC63F"/>
+            <a:srgbClr val="002333"/>
           </a:solidFill>
           <a:ln>
             <a:noFill/>
@@ -3134,20 +3136,61 @@
       </p:sp>
       <p:sp>
         <p:nvSpPr>
-          <p:cNvPr id="3" name="Rectangle 2"/>
-          <p:cNvSpPr/>
+          <p:cNvPr id="3" name="TextBox 2"/>
+          <p:cNvSpPr txBox="1"/>
           <p:nvPr/>
         </p:nvSpPr>
         <p:spPr>
           <a:xfrm>
-            <a:off x="0" y="139700"/>
-            <a:ext cx="12192000" cy="63500"/>
+            <a:off x="1168400" y="1358900"/>
+            <a:ext cx="3175000" cy="406400"/>
           </a:xfrm>
           <a:prstGeom prst="rect">
             <a:avLst/>
           </a:prstGeom>
+          <a:noFill/>
+        </p:spPr>
+        <p:txBody>
+          <a:bodyPr wrap="square" lIns="0" rIns="0" tIns="0" bIns="0">
+            <a:spAutoFit/>
+          </a:bodyPr>
+          <a:lstStyle/>
+          <a:p>
+            <a:pPr algn="l">
+              <a:lnSpc>
+                <a:spcPct val="100000"/>
+              </a:lnSpc>
+            </a:pPr>
+            <a:r>
+              <a:rPr sz="2600" b="1">
+                <a:solidFill>
+                  <a:srgbClr val="00E075"/>
+                </a:solidFill>
+                <a:latin typeface="League Spartan"/>
+              </a:rPr>
+              <a:t>Geld</a:t>
+            </a:r>
+          </a:p>
+        </p:txBody>
+      </p:sp>
+      <p:sp>
+        <p:nvSpPr>
+          <p:cNvPr id="4" name="Rounded Rectangle 3"/>
+          <p:cNvSpPr/>
+          <p:nvPr/>
+        </p:nvSpPr>
+        <p:spPr>
+          <a:xfrm>
+            <a:off x="1168400" y="2101532"/>
+            <a:ext cx="76200" cy="76200"/>
+          </a:xfrm>
+          <a:prstGeom prst="roundRect">
+            <a:avLst>
+              <a:gd name="adj" fmla="val 25000"/>
+            </a:avLst>
+          </a:prstGeom>
           <a:solidFill>
-            <a:srgbClr val="D4E9C2"/>
+            <a:srgbClr val="00E075"/>
           </a:solidFill>
           <a:ln>
             <a:noFill/>
@@ -3178,20 +3221,61 @@
       </p:sp>
       <p:sp>
         <p:nvSpPr>
-          <p:cNvPr id="4" name="Rectangle 3"/>
-          <p:cNvSpPr/>
+          <p:cNvPr id="5" name="TextBox 4"/>
+          <p:cNvSpPr txBox="1"/>
           <p:nvPr/>
         </p:nvSpPr>
         <p:spPr>
           <a:xfrm>
-            <a:off x="762000" y="5715000"/>
-            <a:ext cx="10668000" cy="19050"/>
+            <a:off x="1397000" y="1993900"/>
+            <a:ext cx="2946400" cy="582930"/>
           </a:xfrm>
           <a:prstGeom prst="rect">
             <a:avLst/>
           </a:prstGeom>
+          <a:noFill/>
+        </p:spPr>
+        <p:txBody>
+          <a:bodyPr wrap="square" lIns="0" rIns="0" tIns="0" bIns="0">
+            <a:spAutoFit/>
+          </a:bodyPr>
+          <a:lstStyle/>
+          <a:p>
+            <a:pPr algn="l">
+              <a:lnSpc>
+                <a:spcPct val="135000"/>
+              </a:lnSpc>
+            </a:pPr>
+            <a:r>
+              <a:rPr sz="1700" b="0">
+                <a:solidFill>
+                  <a:srgbClr val="FFFFFF"/>
+                </a:solidFill>
+                <a:latin typeface="Inter"/>
+              </a:rPr>
+              <a:t>PHOV betaalt docenten voor elk uur dat ze beoordelen</a:t>
+            </a:r>
+          </a:p>
+        </p:txBody>
+      </p:sp>
+      <p:sp>
+        <p:nvSpPr>
+          <p:cNvPr id="6" name="Rounded Rectangle 5"/>
+          <p:cNvSpPr/>
+          <p:nvPr/>
+        </p:nvSpPr>
+        <p:spPr>
+          <a:xfrm>
+            <a:off x="1168400" y="2938462"/>
+            <a:ext cx="76200" cy="76200"/>
+          </a:xfrm>
+          <a:prstGeom prst="roundRect">
+            <a:avLst>
+              <a:gd name="adj" fmla="val 25000"/>
+            </a:avLst>
+          </a:prstGeom>
           <a:solidFill>
-            <a:srgbClr val="91B5D4"/>
+            <a:srgbClr val="00E075"/>
           </a:solidFill>
           <a:ln>
             <a:noFill/>
@@ -3220,54 +3304,6 @@
           </a:p>
         </p:txBody>
       </p:sp>
-      <p:pic>
-        <p:nvPicPr>
-          <p:cNvPr id="5" name="Picture 4" descr="klant.png"/>
-          <p:cNvPicPr>
-            <a:picLocks noChangeAspect="1"/>
-          </p:cNvPicPr>
-          <p:nvPr/>
-        </p:nvPicPr>
-        <p:blipFill>
-          <a:blip r:embed="rId2"/>
-          <a:stretch>
-            <a:fillRect/>
-          </a:stretch>
-        </p:blipFill>
-        <p:spPr>
-          <a:xfrm>
-            <a:off x="762000" y="5905500"/>
-            <a:ext cx="571500" cy="571500"/>
-          </a:xfrm>
-          <a:prstGeom prst="rect">
-            <a:avLst/>
-          </a:prstGeom>
-        </p:spPr>
-      </p:pic>
-      <p:pic>
-        <p:nvPicPr>
-          <p:cNvPr id="6" name="Picture 5" descr="logo_navy.png"/>
-          <p:cNvPicPr>
-            <a:picLocks noChangeAspect="1"/>
-          </p:cNvPicPr>
-          <p:nvPr/>
-        </p:nvPicPr>
-        <p:blipFill>
-          <a:blip r:embed="rId3"/>
-          <a:stretch>
-            <a:fillRect/>
-          </a:stretch>
-        </p:blipFill>
-        <p:spPr>
-          <a:xfrm>
-            <a:off x="9906000" y="6083300"/>
-            <a:ext cx="825500" cy="222250"/>
-          </a:xfrm>
-          <a:prstGeom prst="rect">
-            <a:avLst/>
-          </a:prstGeom>
-        </p:spPr>
-      </p:pic>
       <p:sp>
         <p:nvSpPr>
           <p:cNvPr id="7" name="TextBox 6"/>
@@ -3276,8 +3312,8 @@
         </p:nvSpPr>
         <p:spPr>
           <a:xfrm>
-            <a:off x="10922000" y="6096000"/>
-            <a:ext cx="508000" cy="228600"/>
+            <a:off x="1397000" y="2830830"/>
+            <a:ext cx="2946400" cy="582930"/>
           </a:xfrm>
           <a:prstGeom prst="rect">
             <a:avLst/>
@@ -3290,39 +3326,80 @@
           </a:bodyPr>
           <a:lstStyle/>
           <a:p>
-            <a:pPr algn="r">
+            <a:pPr algn="l">
               <a:lnSpc>
-                <a:spcPct val="130000"/>
+                <a:spcPct val="135000"/>
               </a:lnSpc>
             </a:pPr>
             <a:r>
-              <a:rPr sz="1300" b="0">
+              <a:rPr sz="1700" b="0">
                 <a:solidFill>
-                  <a:srgbClr val="6B7A90"/>
+                  <a:srgbClr val="FFFFFF"/>
                 </a:solidFill>
-                <a:latin typeface="Fira Sans"/>
+                <a:latin typeface="Inter"/>
               </a:rPr>
-              <a:t>3</a:t>
-            </a:r>
-          </a:p>
-        </p:txBody>
-      </p:sp>
-      <p:sp>
-        <p:nvSpPr>
-          <p:cNvPr id="8" name="Rectangle 7"/>
-          <p:cNvSpPr/>
+              <a:t>En PHOV eist dat ze feedback geven</a:t>
+            </a:r>
+          </a:p>
+        </p:txBody>
+      </p:sp>
+      <p:sp>
+        <p:nvSpPr>
+          <p:cNvPr id="8" name="TextBox 7"/>
+          <p:cNvSpPr txBox="1"/>
           <p:nvPr/>
         </p:nvSpPr>
         <p:spPr>
           <a:xfrm>
-            <a:off x="762000" y="952500"/>
-            <a:ext cx="3937000" cy="3937000"/>
+            <a:off x="5308600" y="1358900"/>
+            <a:ext cx="5080000" cy="406400"/>
           </a:xfrm>
           <a:prstGeom prst="rect">
             <a:avLst/>
           </a:prstGeom>
+          <a:noFill/>
+        </p:spPr>
+        <p:txBody>
+          <a:bodyPr wrap="square" lIns="0" rIns="0" tIns="0" bIns="0">
+            <a:spAutoFit/>
+          </a:bodyPr>
+          <a:lstStyle/>
+          <a:p>
+            <a:pPr algn="l">
+              <a:lnSpc>
+                <a:spcPct val="100000"/>
+              </a:lnSpc>
+            </a:pPr>
+            <a:r>
+              <a:rPr sz="2600" b="1">
+                <a:solidFill>
+                  <a:srgbClr val="002333"/>
+                </a:solidFill>
+                <a:latin typeface="League Spartan"/>
+              </a:rPr>
+              <a:t>Consistentie</a:t>
+            </a:r>
+          </a:p>
+        </p:txBody>
+      </p:sp>
+      <p:sp>
+        <p:nvSpPr>
+          <p:cNvPr id="9" name="Rounded Rectangle 8"/>
+          <p:cNvSpPr/>
+          <p:nvPr/>
+        </p:nvSpPr>
+        <p:spPr>
+          <a:xfrm>
+            <a:off x="5308600" y="2101532"/>
+            <a:ext cx="76200" cy="76200"/>
+          </a:xfrm>
+          <a:prstGeom prst="roundRect">
+            <a:avLst>
+              <a:gd name="adj" fmla="val 25000"/>
+            </a:avLst>
+          </a:prstGeom>
           <a:solidFill>
-            <a:srgbClr val="112E65"/>
+            <a:srgbClr val="007B54"/>
           </a:solidFill>
           <a:ln>
             <a:noFill/>
@@ -3353,14 +3430,14 @@
       </p:sp>
       <p:sp>
         <p:nvSpPr>
-          <p:cNvPr id="9" name="TextBox 8"/>
+          <p:cNvPr id="10" name="TextBox 9"/>
           <p:cNvSpPr txBox="1"/>
           <p:nvPr/>
         </p:nvSpPr>
         <p:spPr>
           <a:xfrm>
-            <a:off x="1117600" y="1308100"/>
-            <a:ext cx="3302000" cy="381000"/>
+            <a:off x="5537200" y="1993900"/>
+            <a:ext cx="5892800" cy="582930"/>
           </a:xfrm>
           <a:prstGeom prst="rect">
             <a:avLst/>
@@ -3375,39 +3452,39 @@
           <a:p>
             <a:pPr algn="l">
               <a:lnSpc>
-                <a:spcPct val="100000"/>
+                <a:spcPct val="135000"/>
               </a:lnSpc>
             </a:pPr>
             <a:r>
-              <a:rPr sz="2400" b="1">
+              <a:rPr sz="1700" b="0">
                 <a:solidFill>
-                  <a:srgbClr val="8CC63F"/>
+                  <a:srgbClr val="002333"/>
                 </a:solidFill>
-                <a:latin typeface="Barlow Condensed"/>
+                <a:latin typeface="Inter"/>
               </a:rPr>
-              <a:t>GELD</a:t>
-            </a:r>
-          </a:p>
-        </p:txBody>
-      </p:sp>
-      <p:sp>
-        <p:nvSpPr>
-          <p:cNvPr id="10" name="Rounded Rectangle 9"/>
+              <a:t>Vooraf liggen de oordelen van beoordelaars ver uit elkaar, pas na overleg komen ze dichter bij elkaar</a:t>
+            </a:r>
+          </a:p>
+        </p:txBody>
+      </p:sp>
+      <p:sp>
+        <p:nvSpPr>
+          <p:cNvPr id="11" name="Rounded Rectangle 10"/>
           <p:cNvSpPr/>
           <p:nvPr/>
         </p:nvSpPr>
         <p:spPr>
           <a:xfrm>
-            <a:off x="1117600" y="2000885"/>
-            <a:ext cx="88900" cy="88900"/>
+            <a:off x="5308600" y="2887662"/>
+            <a:ext cx="76200" cy="76200"/>
           </a:xfrm>
           <a:prstGeom prst="roundRect">
             <a:avLst>
-              <a:gd name="adj" fmla="val 21428"/>
+              <a:gd name="adj" fmla="val 25000"/>
             </a:avLst>
           </a:prstGeom>
           <a:solidFill>
-            <a:srgbClr val="8CC63F"/>
+            <a:srgbClr val="007B54"/>
           </a:solidFill>
           <a:ln>
             <a:noFill/>
@@ -3438,14 +3515,14 @@
       </p:sp>
       <p:sp>
         <p:nvSpPr>
-          <p:cNvPr id="11" name="TextBox 10"/>
+          <p:cNvPr id="12" name="TextBox 11"/>
           <p:cNvSpPr txBox="1"/>
           <p:nvPr/>
         </p:nvSpPr>
         <p:spPr>
           <a:xfrm>
-            <a:off x="1371600" y="1905000"/>
-            <a:ext cx="3048000" cy="561340"/>
+            <a:off x="5537200" y="2780030"/>
+            <a:ext cx="5892800" cy="582930"/>
           </a:xfrm>
           <a:prstGeom prst="rect">
             <a:avLst/>
@@ -3460,39 +3537,39 @@
           <a:p>
             <a:pPr algn="l">
               <a:lnSpc>
-                <a:spcPct val="130000"/>
+                <a:spcPct val="135000"/>
               </a:lnSpc>
             </a:pPr>
             <a:r>
               <a:rPr sz="1700" b="0">
                 <a:solidFill>
-                  <a:srgbClr val="FFFFFF"/>
+                  <a:srgbClr val="002333"/>
                 </a:solidFill>
-                <a:latin typeface="Fira Sans"/>
+                <a:latin typeface="Inter"/>
               </a:rPr>
-              <a:t>PHOV betaalt docenten voor elk uur dat ze beoordelen</a:t>
-            </a:r>
-          </a:p>
-        </p:txBody>
-      </p:sp>
-      <p:sp>
-        <p:nvSpPr>
-          <p:cNvPr id="12" name="Rounded Rectangle 11"/>
+              <a:t>Daarom kalibreren jullie scripties minstens één keer per twee jaar. De nieuwe rubric is nog niet getest.</a:t>
+            </a:r>
+          </a:p>
+        </p:txBody>
+      </p:sp>
+      <p:sp>
+        <p:nvSpPr>
+          <p:cNvPr id="13" name="Rounded Rectangle 12"/>
           <p:cNvSpPr/>
           <p:nvPr/>
         </p:nvSpPr>
         <p:spPr>
           <a:xfrm>
-            <a:off x="1117600" y="2816225"/>
-            <a:ext cx="88900" cy="88900"/>
+            <a:off x="5308600" y="3673793"/>
+            <a:ext cx="76200" cy="76200"/>
           </a:xfrm>
           <a:prstGeom prst="roundRect">
             <a:avLst>
-              <a:gd name="adj" fmla="val 21428"/>
+              <a:gd name="adj" fmla="val 25000"/>
             </a:avLst>
           </a:prstGeom>
           <a:solidFill>
-            <a:srgbClr val="8CC63F"/>
+            <a:srgbClr val="007B54"/>
           </a:solidFill>
           <a:ln>
             <a:noFill/>
@@ -3523,14 +3600,14 @@
       </p:sp>
       <p:sp>
         <p:nvSpPr>
-          <p:cNvPr id="13" name="TextBox 12"/>
+          <p:cNvPr id="14" name="TextBox 13"/>
           <p:cNvSpPr txBox="1"/>
           <p:nvPr/>
         </p:nvSpPr>
         <p:spPr>
           <a:xfrm>
-            <a:off x="1371600" y="2720340"/>
-            <a:ext cx="3048000" cy="561340"/>
+            <a:off x="5537200" y="3566160"/>
+            <a:ext cx="5892800" cy="582930"/>
           </a:xfrm>
           <a:prstGeom prst="rect">
             <a:avLst/>
@@ -3545,56 +3622,17 @@
           <a:p>
             <a:pPr algn="l">
               <a:lnSpc>
-                <a:spcPct val="130000"/>
+                <a:spcPct val="135000"/>
               </a:lnSpc>
             </a:pPr>
             <a:r>
               <a:rPr sz="1700" b="0">
                 <a:solidFill>
-                  <a:srgbClr val="FFFFFF"/>
+                  <a:srgbClr val="002333"/>
                 </a:solidFill>
-                <a:latin typeface="Fira Sans"/>
+                <a:latin typeface="Inter"/>
               </a:rPr>
-              <a:t>En PHOV eist dat ze feedback geven</a:t>
-            </a:r>
-          </a:p>
-        </p:txBody>
-      </p:sp>
-      <p:sp>
-        <p:nvSpPr>
-          <p:cNvPr id="14" name="TextBox 13"/>
-          <p:cNvSpPr txBox="1"/>
-          <p:nvPr/>
-        </p:nvSpPr>
-        <p:spPr>
-          <a:xfrm>
-            <a:off x="5308600" y="1308100"/>
-            <a:ext cx="5080000" cy="381000"/>
-          </a:xfrm>
-          <a:prstGeom prst="rect">
-            <a:avLst/>
-          </a:prstGeom>
-          <a:noFill/>
-        </p:spPr>
-        <p:txBody>
-          <a:bodyPr wrap="square" lIns="0" rIns="0" tIns="0" bIns="0">
-            <a:spAutoFit/>
-          </a:bodyPr>
-          <a:lstStyle/>
-          <a:p>
-            <a:pPr algn="l">
-              <a:lnSpc>
-                <a:spcPct val="100000"/>
-              </a:lnSpc>
-            </a:pPr>
-            <a:r>
-              <a:rPr sz="2400" b="1">
-                <a:solidFill>
-                  <a:srgbClr val="69AA13"/>
-                </a:solidFill>
-                <a:latin typeface="Barlow Condensed"/>
-              </a:rPr>
-              <a:t>CONSISTENTIE</a:t>
+              <a:t>Kalibratie hoort over de inhoud te gaan, maar gaat soms over handtekeningen op een formulier</a:t>
             </a:r>
           </a:p>
         </p:txBody>
@@ -3607,16 +3645,16 @@
         </p:nvSpPr>
         <p:spPr>
           <a:xfrm>
-            <a:off x="5308600" y="2000885"/>
-            <a:ext cx="88900" cy="88900"/>
+            <a:off x="5308600" y="4459923"/>
+            <a:ext cx="76200" cy="76200"/>
           </a:xfrm>
           <a:prstGeom prst="roundRect">
             <a:avLst>
-              <a:gd name="adj" fmla="val 21428"/>
+              <a:gd name="adj" fmla="val 25000"/>
             </a:avLst>
           </a:prstGeom>
           <a:solidFill>
-            <a:srgbClr val="8CC63F"/>
+            <a:srgbClr val="007B54"/>
           </a:solidFill>
           <a:ln>
             <a:noFill/>
@@ -3653,8 +3691,8 @@
         </p:nvSpPr>
         <p:spPr>
           <a:xfrm>
-            <a:off x="5562600" y="1905000"/>
-            <a:ext cx="5867400" cy="561340"/>
+            <a:off x="5537200" y="4352290"/>
+            <a:ext cx="5892800" cy="291465"/>
           </a:xfrm>
           <a:prstGeom prst="rect">
             <a:avLst/>
@@ -3669,39 +3707,37 @@
           <a:p>
             <a:pPr algn="l">
               <a:lnSpc>
-                <a:spcPct val="130000"/>
+                <a:spcPct val="135000"/>
               </a:lnSpc>
             </a:pPr>
             <a:r>
               <a:rPr sz="1700" b="0">
                 <a:solidFill>
-                  <a:srgbClr val="112E65"/>
+                  <a:srgbClr val="002333"/>
                 </a:solidFill>
-                <a:latin typeface="Fira Sans"/>
+                <a:latin typeface="Inter"/>
               </a:rPr>
-              <a:t>Vooraf liggen de oordelen van beoordelaars ver uit elkaar, pas na overleg komen ze dichter bij elkaar</a:t>
-            </a:r>
-          </a:p>
-        </p:txBody>
-      </p:sp>
-      <p:sp>
-        <p:nvSpPr>
-          <p:cNvPr id="17" name="Rounded Rectangle 16"/>
+              <a:t>De directie schuift zelf aan om mensen scherp te houden</a:t>
+            </a:r>
+          </a:p>
+        </p:txBody>
+      </p:sp>
+      <p:sp>
+        <p:nvSpPr>
+          <p:cNvPr id="17" name="Rectangle 16"/>
           <p:cNvSpPr/>
           <p:nvPr/>
         </p:nvSpPr>
         <p:spPr>
           <a:xfrm>
-            <a:off x="5308600" y="2752725"/>
-            <a:ext cx="88900" cy="88900"/>
+            <a:off x="762000" y="5511800"/>
+            <a:ext cx="10668000" cy="6350"/>
           </a:xfrm>
-          <a:prstGeom prst="roundRect">
-            <a:avLst>
-              <a:gd name="adj" fmla="val 21428"/>
-            </a:avLst>
+          <a:prstGeom prst="rect">
+            <a:avLst/>
           </a:prstGeom>
           <a:solidFill>
-            <a:srgbClr val="8CC63F"/>
+            <a:srgbClr val="E7EEF0"/>
           </a:solidFill>
           <a:ln>
             <a:noFill/>
@@ -3730,63 +3766,46 @@
           </a:p>
         </p:txBody>
       </p:sp>
-      <p:sp>
-        <p:nvSpPr>
-          <p:cNvPr id="18" name="TextBox 17"/>
-          <p:cNvSpPr txBox="1"/>
+      <p:pic>
+        <p:nvPicPr>
+          <p:cNvPr id="18" name="Picture 17" descr="logo_navy.png"/>
+          <p:cNvPicPr>
+            <a:picLocks noChangeAspect="1"/>
+          </p:cNvPicPr>
           <p:nvPr/>
-        </p:nvSpPr>
+        </p:nvPicPr>
+        <p:blipFill>
+          <a:blip r:embed="rId2"/>
+          <a:stretch>
+            <a:fillRect/>
+          </a:stretch>
+        </p:blipFill>
         <p:spPr>
           <a:xfrm>
-            <a:off x="5562600" y="2656840"/>
-            <a:ext cx="5867400" cy="561340"/>
+            <a:off x="9010650" y="5759450"/>
+            <a:ext cx="1079500" cy="292100"/>
           </a:xfrm>
           <a:prstGeom prst="rect">
             <a:avLst/>
           </a:prstGeom>
-          <a:noFill/>
         </p:spPr>
-        <p:txBody>
-          <a:bodyPr wrap="square" lIns="0" rIns="0" tIns="0" bIns="0">
-            <a:spAutoFit/>
-          </a:bodyPr>
-          <a:lstStyle/>
-          <a:p>
-            <a:pPr algn="l">
-              <a:lnSpc>
-                <a:spcPct val="130000"/>
-              </a:lnSpc>
-            </a:pPr>
-            <a:r>
-              <a:rPr sz="1700" b="0">
-                <a:solidFill>
-                  <a:srgbClr val="112E65"/>
-                </a:solidFill>
-                <a:latin typeface="Fira Sans"/>
-              </a:rPr>
-              <a:t>Daarom kalibreren jullie scripties minstens één keer per twee jaar. De nieuwe rubric is nog niet getest.</a:t>
-            </a:r>
-          </a:p>
-        </p:txBody>
-      </p:sp>
-      <p:sp>
-        <p:nvSpPr>
-          <p:cNvPr id="19" name="Rounded Rectangle 18"/>
+      </p:pic>
+      <p:sp>
+        <p:nvSpPr>
+          <p:cNvPr id="19" name="Rectangle 18"/>
           <p:cNvSpPr/>
           <p:nvPr/>
         </p:nvSpPr>
         <p:spPr>
           <a:xfrm>
-            <a:off x="5308600" y="3504565"/>
-            <a:ext cx="88900" cy="88900"/>
+            <a:off x="10344150" y="5740400"/>
+            <a:ext cx="6350" cy="330200"/>
           </a:xfrm>
-          <a:prstGeom prst="roundRect">
-            <a:avLst>
-              <a:gd name="adj" fmla="val 21428"/>
-            </a:avLst>
+          <a:prstGeom prst="rect">
+            <a:avLst/>
           </a:prstGeom>
           <a:solidFill>
-            <a:srgbClr val="8CC63F"/>
+            <a:srgbClr val="CDD9DE"/>
           </a:solidFill>
           <a:ln>
             <a:noFill/>
@@ -3815,16 +3834,40 @@
           </a:p>
         </p:txBody>
       </p:sp>
-      <p:sp>
-        <p:nvSpPr>
-          <p:cNvPr id="20" name="TextBox 19"/>
+      <p:pic>
+        <p:nvPicPr>
+          <p:cNvPr id="20" name="Picture 19" descr="klant.png"/>
+          <p:cNvPicPr>
+            <a:picLocks noChangeAspect="1"/>
+          </p:cNvPicPr>
+          <p:nvPr/>
+        </p:nvPicPr>
+        <p:blipFill>
+          <a:blip r:embed="rId3"/>
+          <a:stretch>
+            <a:fillRect/>
+          </a:stretch>
+        </p:blipFill>
+        <p:spPr>
+          <a:xfrm>
+            <a:off x="10604500" y="5715000"/>
+            <a:ext cx="381000" cy="381000"/>
+          </a:xfrm>
+          <a:prstGeom prst="rect">
+            <a:avLst/>
+          </a:prstGeom>
+        </p:spPr>
+      </p:pic>
+      <p:sp>
+        <p:nvSpPr>
+          <p:cNvPr id="21" name="TextBox 20"/>
           <p:cNvSpPr txBox="1"/>
           <p:nvPr/>
         </p:nvSpPr>
         <p:spPr>
           <a:xfrm>
-            <a:off x="5562600" y="3408680"/>
-            <a:ext cx="5867400" cy="561340"/>
+            <a:off x="10795000" y="6375400"/>
+            <a:ext cx="635000" cy="228600"/>
           </a:xfrm>
           <a:prstGeom prst="rect">
             <a:avLst/>
@@ -3837,104 +3880,19 @@
           </a:bodyPr>
           <a:lstStyle/>
           <a:p>
-            <a:pPr algn="l">
+            <a:pPr algn="r">
               <a:lnSpc>
-                <a:spcPct val="130000"/>
+                <a:spcPct val="115000"/>
               </a:lnSpc>
             </a:pPr>
             <a:r>
-              <a:rPr sz="1700" b="0">
+              <a:rPr sz="1150" b="0">
                 <a:solidFill>
-                  <a:srgbClr val="112E65"/>
+                  <a:srgbClr val="9AAFB8"/>
                 </a:solidFill>
-                <a:latin typeface="Fira Sans"/>
+                <a:latin typeface="Inter"/>
               </a:rPr>
-              <a:t>Kalibratie hoort over de inhoud te gaan, maar gaat soms over handtekeningen op een formulier</a:t>
-            </a:r>
-          </a:p>
-        </p:txBody>
-      </p:sp>
-      <p:sp>
-        <p:nvSpPr>
-          <p:cNvPr id="21" name="Rounded Rectangle 20"/>
-          <p:cNvSpPr/>
-          <p:nvPr/>
-        </p:nvSpPr>
-        <p:spPr>
-          <a:xfrm>
-            <a:off x="5308600" y="4256405"/>
-            <a:ext cx="88900" cy="88900"/>
-          </a:xfrm>
-          <a:prstGeom prst="roundRect">
-            <a:avLst>
-              <a:gd name="adj" fmla="val 21428"/>
-            </a:avLst>
-          </a:prstGeom>
-          <a:solidFill>
-            <a:srgbClr val="8CC63F"/>
-          </a:solidFill>
-          <a:ln>
-            <a:noFill/>
-          </a:ln>
-          <a:effectLst/>
-        </p:spPr>
-        <p:style>
-          <a:lnRef idx="1">
-            <a:schemeClr val="accent1"/>
-          </a:lnRef>
-          <a:fillRef idx="3">
-            <a:schemeClr val="accent1"/>
-          </a:fillRef>
-          <a:effectRef idx="2">
-            <a:schemeClr val="accent1"/>
-          </a:effectRef>
-          <a:fontRef idx="minor">
-            <a:schemeClr val="lt1"/>
-          </a:fontRef>
-        </p:style>
-        <p:txBody>
-          <a:bodyPr rtlCol="0" anchor="ctr"/>
-          <a:lstStyle/>
-          <a:p>
-            <a:pPr algn="ctr"/>
-          </a:p>
-        </p:txBody>
-      </p:sp>
-      <p:sp>
-        <p:nvSpPr>
-          <p:cNvPr id="22" name="TextBox 21"/>
-          <p:cNvSpPr txBox="1"/>
-          <p:nvPr/>
-        </p:nvSpPr>
-        <p:spPr>
-          <a:xfrm>
-            <a:off x="5562600" y="4160520"/>
-            <a:ext cx="5867400" cy="280670"/>
-          </a:xfrm>
-          <a:prstGeom prst="rect">
-            <a:avLst/>
-          </a:prstGeom>
-          <a:noFill/>
-        </p:spPr>
-        <p:txBody>
-          <a:bodyPr wrap="square" lIns="0" rIns="0" tIns="0" bIns="0">
-            <a:spAutoFit/>
-          </a:bodyPr>
-          <a:lstStyle/>
-          <a:p>
-            <a:pPr algn="l">
-              <a:lnSpc>
-                <a:spcPct val="130000"/>
-              </a:lnSpc>
-            </a:pPr>
-            <a:r>
-              <a:rPr sz="1700" b="0">
-                <a:solidFill>
-                  <a:srgbClr val="112E65"/>
-                </a:solidFill>
-                <a:latin typeface="Fira Sans"/>
-              </a:rPr>
-              <a:t>De directie schuift zelf aan om mensen scherp te houden</a:t>
+              <a:t>3</a:t>
             </a:r>
           </a:p>
         </p:txBody>

</xml_diff>